<commit_message>
Fix slide 4 workflow: compute box positions so arrows are visible
Replaced hardcoded step positions with a computed layout that reserves
0.42" per arrow gap, giving each of the 6 boxes ~1.78" width and
keeping the chain within the slide margins.

https://claude.ai/code/session_01PgK1i2V1rgZvPiD9YEwuxF
</commit_message>
<xml_diff>
--- a/agents4geos_slides.pptx
+++ b/agents4geos_slides.pptx
@@ -9324,8 +9324,8 @@
         </p:nvSpPr>
         <p:spPr>
           <a:xfrm>
-            <a:off x="274320" y="822960"/>
-            <a:ext cx="1783080" cy="1280160"/>
+            <a:off x="256032" y="822960"/>
+            <a:ext cx="1626108" cy="1234440"/>
           </a:xfrm>
           <a:prstGeom prst="rect">
             <a:avLst/>
@@ -9367,8 +9367,8 @@
         </p:nvSpPr>
         <p:spPr>
           <a:xfrm>
-            <a:off x="320040" y="914400"/>
-            <a:ext cx="1691639" cy="1143000"/>
+            <a:off x="301752" y="896112"/>
+            <a:ext cx="1534668" cy="1124712"/>
           </a:xfrm>
           <a:prstGeom prst="rect">
             <a:avLst/>
@@ -9383,7 +9383,7 @@
           <a:p>
             <a:pPr algn="ctr"/>
             <a:r>
-              <a:rPr sz="1300" b="1" i="0">
+              <a:rPr sz="1200" b="1" i="0">
                 <a:solidFill>
                   <a:srgbClr val="1A1A2E"/>
                 </a:solidFill>
@@ -9403,8 +9403,8 @@
         </p:nvSpPr>
         <p:spPr>
           <a:xfrm>
-            <a:off x="2075688" y="1234440"/>
-            <a:ext cx="292608" cy="457200"/>
+            <a:off x="1891284" y="1207008"/>
+            <a:ext cx="365760" cy="457200"/>
           </a:xfrm>
           <a:prstGeom prst="rect">
             <a:avLst/>
@@ -9419,7 +9419,7 @@
           <a:p>
             <a:pPr algn="ctr"/>
             <a:r>
-              <a:rPr sz="2000" b="1" i="0">
+              <a:rPr sz="1800" b="1" i="0">
                 <a:solidFill>
                   <a:srgbClr val="CCCCCC"/>
                 </a:solidFill>
@@ -9437,8 +9437,8 @@
         </p:nvSpPr>
         <p:spPr>
           <a:xfrm>
-            <a:off x="2194560" y="822960"/>
-            <a:ext cx="1783080" cy="1280160"/>
+            <a:off x="2266188" y="822960"/>
+            <a:ext cx="1626108" cy="1234440"/>
           </a:xfrm>
           <a:prstGeom prst="rect">
             <a:avLst/>
@@ -9480,8 +9480,8 @@
         </p:nvSpPr>
         <p:spPr>
           <a:xfrm>
-            <a:off x="2240279" y="914400"/>
-            <a:ext cx="1691639" cy="1143000"/>
+            <a:off x="2311908" y="896112"/>
+            <a:ext cx="1534668" cy="1124712"/>
           </a:xfrm>
           <a:prstGeom prst="rect">
             <a:avLst/>
@@ -9496,7 +9496,7 @@
           <a:p>
             <a:pPr algn="ctr"/>
             <a:r>
-              <a:rPr sz="1300" b="0" i="0">
+              <a:rPr sz="1200" b="0" i="0">
                 <a:solidFill>
                   <a:srgbClr val="1A1A2E"/>
                 </a:solidFill>
@@ -9515,8 +9515,8 @@
         </p:nvSpPr>
         <p:spPr>
           <a:xfrm>
-            <a:off x="3995927" y="1234440"/>
-            <a:ext cx="292608" cy="457200"/>
+            <a:off x="3901440" y="1207008"/>
+            <a:ext cx="365760" cy="457200"/>
           </a:xfrm>
           <a:prstGeom prst="rect">
             <a:avLst/>
@@ -9531,7 +9531,7 @@
           <a:p>
             <a:pPr algn="ctr"/>
             <a:r>
-              <a:rPr sz="2000" b="1" i="0">
+              <a:rPr sz="1800" b="1" i="0">
                 <a:solidFill>
                   <a:srgbClr val="CCCCCC"/>
                 </a:solidFill>
@@ -9549,8 +9549,8 @@
         </p:nvSpPr>
         <p:spPr>
           <a:xfrm>
-            <a:off x="4114800" y="822960"/>
-            <a:ext cx="1783080" cy="1280160"/>
+            <a:off x="4276344" y="822960"/>
+            <a:ext cx="1626108" cy="1234440"/>
           </a:xfrm>
           <a:prstGeom prst="rect">
             <a:avLst/>
@@ -9592,8 +9592,8 @@
         </p:nvSpPr>
         <p:spPr>
           <a:xfrm>
-            <a:off x="4160520" y="914400"/>
-            <a:ext cx="1691639" cy="1143000"/>
+            <a:off x="4322064" y="896112"/>
+            <a:ext cx="1534668" cy="1124712"/>
           </a:xfrm>
           <a:prstGeom prst="rect">
             <a:avLst/>
@@ -9608,7 +9608,7 @@
           <a:p>
             <a:pPr algn="ctr"/>
             <a:r>
-              <a:rPr sz="1300" b="0" i="0">
+              <a:rPr sz="1200" b="0" i="0">
                 <a:solidFill>
                   <a:srgbClr val="1A1A2E"/>
                 </a:solidFill>
@@ -9627,8 +9627,8 @@
         </p:nvSpPr>
         <p:spPr>
           <a:xfrm>
-            <a:off x="5916168" y="1234440"/>
-            <a:ext cx="292608" cy="457200"/>
+            <a:off x="5911596" y="1207008"/>
+            <a:ext cx="365760" cy="457200"/>
           </a:xfrm>
           <a:prstGeom prst="rect">
             <a:avLst/>
@@ -9643,7 +9643,7 @@
           <a:p>
             <a:pPr algn="ctr"/>
             <a:r>
-              <a:rPr sz="2000" b="1" i="0">
+              <a:rPr sz="1800" b="1" i="0">
                 <a:solidFill>
                   <a:srgbClr val="CCCCCC"/>
                 </a:solidFill>
@@ -9661,8 +9661,8 @@
         </p:nvSpPr>
         <p:spPr>
           <a:xfrm>
-            <a:off x="6035040" y="822960"/>
-            <a:ext cx="1783080" cy="1280160"/>
+            <a:off x="6286500" y="822960"/>
+            <a:ext cx="1626108" cy="1234440"/>
           </a:xfrm>
           <a:prstGeom prst="rect">
             <a:avLst/>
@@ -9704,8 +9704,8 @@
         </p:nvSpPr>
         <p:spPr>
           <a:xfrm>
-            <a:off x="6080759" y="914400"/>
-            <a:ext cx="1691639" cy="1143000"/>
+            <a:off x="6332220" y="896112"/>
+            <a:ext cx="1534668" cy="1124712"/>
           </a:xfrm>
           <a:prstGeom prst="rect">
             <a:avLst/>
@@ -9720,7 +9720,7 @@
           <a:p>
             <a:pPr algn="ctr"/>
             <a:r>
-              <a:rPr sz="1300" b="0" i="0">
+              <a:rPr sz="1200" b="0" i="0">
                 <a:solidFill>
                   <a:srgbClr val="1A1A2E"/>
                 </a:solidFill>
@@ -9739,8 +9739,8 @@
         </p:nvSpPr>
         <p:spPr>
           <a:xfrm>
-            <a:off x="7836407" y="1234440"/>
-            <a:ext cx="292608" cy="457200"/>
+            <a:off x="7921752" y="1207008"/>
+            <a:ext cx="365760" cy="457200"/>
           </a:xfrm>
           <a:prstGeom prst="rect">
             <a:avLst/>
@@ -9755,7 +9755,7 @@
           <a:p>
             <a:pPr algn="ctr"/>
             <a:r>
-              <a:rPr sz="2000" b="1" i="0">
+              <a:rPr sz="1800" b="1" i="0">
                 <a:solidFill>
                   <a:srgbClr val="CCCCCC"/>
                 </a:solidFill>
@@ -9773,8 +9773,8 @@
         </p:nvSpPr>
         <p:spPr>
           <a:xfrm>
-            <a:off x="7955279" y="822960"/>
-            <a:ext cx="1783080" cy="1280160"/>
+            <a:off x="8296655" y="822960"/>
+            <a:ext cx="1626108" cy="1234440"/>
           </a:xfrm>
           <a:prstGeom prst="rect">
             <a:avLst/>
@@ -9816,8 +9816,8 @@
         </p:nvSpPr>
         <p:spPr>
           <a:xfrm>
-            <a:off x="8001000" y="914400"/>
-            <a:ext cx="1691639" cy="1143000"/>
+            <a:off x="8342376" y="896112"/>
+            <a:ext cx="1534668" cy="1124712"/>
           </a:xfrm>
           <a:prstGeom prst="rect">
             <a:avLst/>
@@ -9832,7 +9832,7 @@
           <a:p>
             <a:pPr algn="ctr"/>
             <a:r>
-              <a:rPr sz="1300" b="0" i="0">
+              <a:rPr sz="1200" b="0" i="0">
                 <a:solidFill>
                   <a:srgbClr val="1A1A2E"/>
                 </a:solidFill>
@@ -9851,8 +9851,8 @@
         </p:nvSpPr>
         <p:spPr>
           <a:xfrm>
-            <a:off x="9756647" y="1234440"/>
-            <a:ext cx="292608" cy="457200"/>
+            <a:off x="9931908" y="1207008"/>
+            <a:ext cx="365760" cy="457200"/>
           </a:xfrm>
           <a:prstGeom prst="rect">
             <a:avLst/>
@@ -9867,7 +9867,7 @@
           <a:p>
             <a:pPr algn="ctr"/>
             <a:r>
-              <a:rPr sz="2000" b="1" i="0">
+              <a:rPr sz="1800" b="1" i="0">
                 <a:solidFill>
                   <a:srgbClr val="CCCCCC"/>
                 </a:solidFill>
@@ -9885,8 +9885,8 @@
         </p:nvSpPr>
         <p:spPr>
           <a:xfrm>
-            <a:off x="9875520" y="822960"/>
-            <a:ext cx="1783080" cy="1280160"/>
+            <a:off x="10306812" y="822960"/>
+            <a:ext cx="1626108" cy="1234440"/>
           </a:xfrm>
           <a:prstGeom prst="rect">
             <a:avLst/>
@@ -9928,8 +9928,8 @@
         </p:nvSpPr>
         <p:spPr>
           <a:xfrm>
-            <a:off x="9921240" y="914400"/>
-            <a:ext cx="1691639" cy="1143000"/>
+            <a:off x="10352532" y="896112"/>
+            <a:ext cx="1534668" cy="1124712"/>
           </a:xfrm>
           <a:prstGeom prst="rect">
             <a:avLst/>
@@ -9944,7 +9944,7 @@
           <a:p>
             <a:pPr algn="ctr"/>
             <a:r>
-              <a:rPr sz="1300" b="0" i="0">
+              <a:rPr sz="1200" b="0" i="0">
                 <a:solidFill>
                   <a:srgbClr val="1A1A2E"/>
                 </a:solidFill>

</xml_diff>